<commit_message>
Zmień kolorystykę na barwy marek Apple/Samsung (grafit + niebieski)
Co-authored-by: mattty1 <mattty1@users.noreply.github.com>
</commit_message>
<xml_diff>
--- a/Prezentacja_iPhone_vs_Samsung.pptx
+++ b/Prezentacja_iPhone_vs_Samsung.pptx
@@ -132,7 +132,7 @@
             <a:pPr>
               <a:defRPr sz="1500" b="1">
                 <a:solidFill>
-                  <a:srgbClr val="1E1B2E"/>
+                  <a:srgbClr val="1D1D1F"/>
                 </a:solidFill>
               </a:defRPr>
             </a:pPr>
@@ -168,7 +168,7 @@
             <c:idx val="0"/>
             <c:spPr>
               <a:solidFill>
-                <a:srgbClr val="EC4B9C"/>
+                <a:srgbClr val="1428A0"/>
               </a:solidFill>
             </c:spPr>
           </c:dPt>
@@ -176,7 +176,7 @@
             <c:idx val="1"/>
             <c:spPr>
               <a:solidFill>
-                <a:srgbClr val="3B82F6"/>
+                <a:srgbClr val="1B6EF3"/>
               </a:solidFill>
             </c:spPr>
           </c:dPt>
@@ -184,7 +184,7 @@
             <c:idx val="2"/>
             <c:spPr>
               <a:solidFill>
-                <a:srgbClr val="F5A623"/>
+                <a:srgbClr val="5AC8FA"/>
               </a:solidFill>
             </c:spPr>
           </c:dPt>
@@ -267,7 +267,7 @@
       <a:pPr>
         <a:defRPr sz="1100">
           <a:solidFill>
-            <a:srgbClr val="1E1B2E"/>
+            <a:srgbClr val="1D1D1F"/>
           </a:solidFill>
           <a:latin typeface="Calibri"/>
         </a:defRPr>
@@ -294,7 +294,7 @@
             <a:pPr>
               <a:defRPr sz="1500" b="1">
                 <a:solidFill>
-                  <a:srgbClr val="1E1B2E"/>
+                  <a:srgbClr val="1D1D1F"/>
                 </a:solidFill>
               </a:defRPr>
             </a:pPr>
@@ -330,7 +330,7 @@
             <c:idx val="0"/>
             <c:spPr>
               <a:solidFill>
-                <a:srgbClr val="6D28D9"/>
+                <a:srgbClr val="0071E3"/>
               </a:solidFill>
             </c:spPr>
           </c:dPt>
@@ -338,7 +338,7 @@
             <c:idx val="1"/>
             <c:spPr>
               <a:solidFill>
-                <a:srgbClr val="EC4B9C"/>
+                <a:srgbClr val="1428A0"/>
               </a:solidFill>
             </c:spPr>
           </c:dPt>
@@ -346,7 +346,7 @@
             <c:idx val="2"/>
             <c:spPr>
               <a:solidFill>
-                <a:srgbClr val="14B8A6"/>
+                <a:srgbClr val="009DDC"/>
               </a:solidFill>
             </c:spPr>
           </c:dPt>
@@ -354,7 +354,7 @@
             <c:idx val="3"/>
             <c:spPr>
               <a:solidFill>
-                <a:srgbClr val="F5A623"/>
+                <a:srgbClr val="5AC8FA"/>
               </a:solidFill>
             </c:spPr>
           </c:dPt>
@@ -362,7 +362,7 @@
             <c:idx val="4"/>
             <c:spPr>
               <a:solidFill>
-                <a:srgbClr val="FB704C"/>
+                <a:srgbClr val="48484A"/>
               </a:solidFill>
             </c:spPr>
           </c:dPt>
@@ -370,7 +370,7 @@
             <c:idx val="5"/>
             <c:spPr>
               <a:solidFill>
-                <a:srgbClr val="3B82F6"/>
+                <a:srgbClr val="1B6EF3"/>
               </a:solidFill>
             </c:spPr>
           </c:dPt>
@@ -490,7 +490,7 @@
       <a:pPr>
         <a:defRPr sz="1100">
           <a:solidFill>
-            <a:srgbClr val="1E1B2E"/>
+            <a:srgbClr val="1D1D1F"/>
           </a:solidFill>
           <a:latin typeface="Calibri"/>
         </a:defRPr>
@@ -752,7 +752,7 @@
       <a:pPr>
         <a:defRPr sz="1100">
           <a:solidFill>
-            <a:srgbClr val="1E1B2E"/>
+            <a:srgbClr val="1D1D1F"/>
           </a:solidFill>
           <a:latin typeface="Calibri"/>
         </a:defRPr>
@@ -778,7 +778,7 @@
             <a:pPr>
               <a:defRPr sz="1350" b="1">
                 <a:solidFill>
-                  <a:srgbClr val="1E1B2E"/>
+                  <a:srgbClr val="1D1D1F"/>
                 </a:solidFill>
               </a:defRPr>
             </a:pPr>
@@ -813,7 +813,7 @@
             <c:idx val="0"/>
             <c:spPr>
               <a:solidFill>
-                <a:srgbClr val="22C55E"/>
+                <a:srgbClr val="0A84FF"/>
               </a:solidFill>
             </c:spPr>
           </c:dPt>
@@ -821,7 +821,7 @@
             <c:idx val="1"/>
             <c:spPr>
               <a:solidFill>
-                <a:srgbClr val="6B6680"/>
+                <a:srgbClr val="86868B"/>
               </a:solidFill>
             </c:spPr>
           </c:dPt>
@@ -829,7 +829,7 @@
             <c:idx val="2"/>
             <c:spPr>
               <a:solidFill>
-                <a:srgbClr val="EC4B9C"/>
+                <a:srgbClr val="1428A0"/>
               </a:solidFill>
             </c:spPr>
           </c:dPt>
@@ -907,7 +907,7 @@
       <a:pPr>
         <a:defRPr sz="1100">
           <a:solidFill>
-            <a:srgbClr val="1E1B2E"/>
+            <a:srgbClr val="1D1D1F"/>
           </a:solidFill>
           <a:latin typeface="Calibri"/>
         </a:defRPr>
@@ -970,7 +970,7 @@
             <c:idx val="0"/>
             <c:spPr>
               <a:solidFill>
-                <a:srgbClr val="F5A623"/>
+                <a:srgbClr val="5AC8FA"/>
               </a:solidFill>
             </c:spPr>
           </c:dPt>
@@ -978,7 +978,7 @@
             <c:idx val="1"/>
             <c:spPr>
               <a:solidFill>
-                <a:srgbClr val="3B82F6"/>
+                <a:srgbClr val="1B6EF3"/>
               </a:solidFill>
             </c:spPr>
           </c:dPt>
@@ -986,7 +986,7 @@
             <c:idx val="2"/>
             <c:spPr>
               <a:solidFill>
-                <a:srgbClr val="EC4B9C"/>
+                <a:srgbClr val="1428A0"/>
               </a:solidFill>
             </c:spPr>
           </c:dPt>
@@ -4117,10 +4117,10 @@
           <a:gradFill>
             <a:gsLst>
               <a:gs pos="0">
-                <a:srgbClr val="3B0A6B"/>
+                <a:srgbClr val="0A122A"/>
               </a:gs>
               <a:gs pos="100000">
-                <a:srgbClr val="6D28D9"/>
+                <a:srgbClr val="0071E3"/>
               </a:gs>
             </a:gsLst>
             <a:lin ang="3600000" scaled="1"/>
@@ -4169,10 +4169,10 @@
           <a:gradFill>
             <a:gsLst>
               <a:gs pos="0">
-                <a:srgbClr val="EC4B9C"/>
+                <a:srgbClr val="1428A0"/>
               </a:gs>
               <a:gs pos="100000">
-                <a:srgbClr val="FB704C"/>
+                <a:srgbClr val="48484A"/>
               </a:gs>
             </a:gsLst>
             <a:lin ang="2700000" scaled="1"/>
@@ -4221,10 +4221,10 @@
           <a:gradFill>
             <a:gsLst>
               <a:gs pos="0">
-                <a:srgbClr val="14B8A6"/>
+                <a:srgbClr val="009DDC"/>
               </a:gs>
               <a:gs pos="100000">
-                <a:srgbClr val="3B82F6"/>
+                <a:srgbClr val="1B6EF3"/>
               </a:gs>
             </a:gsLst>
             <a:lin ang="2700000" scaled="1"/>
@@ -4271,7 +4271,7 @@
             <a:avLst/>
           </a:prstGeom>
           <a:solidFill>
-            <a:srgbClr val="F5A623"/>
+            <a:srgbClr val="5AC8FA"/>
           </a:solidFill>
           <a:ln>
             <a:noFill/>
@@ -4315,7 +4315,7 @@
             <a:avLst/>
           </a:prstGeom>
           <a:solidFill>
-            <a:srgbClr val="EC4B9C"/>
+            <a:srgbClr val="1428A0"/>
           </a:solidFill>
           <a:ln>
             <a:noFill/>
@@ -4634,7 +4634,7 @@
             <a:r>
               <a:rPr sz="4000" b="1" i="1">
                 <a:solidFill>
-                  <a:srgbClr val="F5A623"/>
+                  <a:srgbClr val="5AC8FA"/>
                 </a:solidFill>
                 <a:latin typeface="Calibri"/>
               </a:rPr>
@@ -4756,7 +4756,7 @@
             <a:r>
               <a:rPr sz="1300" b="1" i="0">
                 <a:solidFill>
-                  <a:srgbClr val="6D28D9"/>
+                  <a:srgbClr val="0071E3"/>
                 </a:solidFill>
                 <a:latin typeface="Calibri"/>
               </a:rPr>
@@ -4765,7 +4765,7 @@
             <a:r>
               <a:rPr sz="1300" b="0" i="0">
                 <a:solidFill>
-                  <a:srgbClr val="1E1B2E"/>
+                  <a:srgbClr val="1D1D1F"/>
                 </a:solidFill>
                 <a:latin typeface="Calibri"/>
               </a:rPr>
@@ -4787,7 +4787,7 @@
             <a:r>
               <a:rPr sz="1150" b="0" i="1">
                 <a:solidFill>
-                  <a:srgbClr val="6B6680"/>
+                  <a:srgbClr val="86868B"/>
                 </a:solidFill>
                 <a:latin typeface="Calibri"/>
               </a:rPr>
@@ -4829,7 +4829,7 @@
             <a:avLst/>
           </a:prstGeom>
           <a:solidFill>
-            <a:srgbClr val="F6F4FD"/>
+            <a:srgbClr val="F5F5F7"/>
           </a:solidFill>
           <a:ln>
             <a:noFill/>
@@ -4875,7 +4875,7 @@
             </a:avLst>
           </a:prstGeom>
           <a:solidFill>
-            <a:srgbClr val="14B8A6"/>
+            <a:srgbClr val="009DDC"/>
           </a:solidFill>
           <a:ln>
             <a:noFill/>
@@ -4985,7 +4985,7 @@
             <a:r>
               <a:rPr sz="3400" b="1" i="0">
                 <a:solidFill>
-                  <a:srgbClr val="1E1B2E"/>
+                  <a:srgbClr val="1D1D1F"/>
                 </a:solidFill>
                 <a:latin typeface="Calibri"/>
               </a:rPr>
@@ -5009,7 +5009,7 @@
             <a:avLst/>
           </a:prstGeom>
           <a:solidFill>
-            <a:srgbClr val="14B8A6"/>
+            <a:srgbClr val="009DDC"/>
           </a:solidFill>
           <a:ln>
             <a:noFill/>
@@ -5106,7 +5106,7 @@
             <a:avLst/>
           </a:prstGeom>
           <a:solidFill>
-            <a:srgbClr val="6D28D9"/>
+            <a:srgbClr val="0071E3"/>
           </a:solidFill>
           <a:ln>
             <a:noFill/>
@@ -5216,7 +5216,7 @@
             <a:r>
               <a:rPr sz="1600" b="0" i="0">
                 <a:solidFill>
-                  <a:srgbClr val="1E1B2E"/>
+                  <a:srgbClr val="1D1D1F"/>
                 </a:solidFill>
                 <a:latin typeface="Calibri"/>
               </a:rPr>
@@ -5242,7 +5242,7 @@
             </a:avLst>
           </a:prstGeom>
           <a:solidFill>
-            <a:srgbClr val="22C55E"/>
+            <a:srgbClr val="0A84FF"/>
           </a:solidFill>
           <a:ln>
             <a:noFill/>
@@ -5384,7 +5384,7 @@
             <a:avLst/>
           </a:prstGeom>
           <a:solidFill>
-            <a:srgbClr val="6D28D9"/>
+            <a:srgbClr val="0071E3"/>
           </a:solidFill>
           <a:ln>
             <a:noFill/>
@@ -5494,7 +5494,7 @@
             <a:r>
               <a:rPr sz="1600" b="0" i="0">
                 <a:solidFill>
-                  <a:srgbClr val="1E1B2E"/>
+                  <a:srgbClr val="1D1D1F"/>
                 </a:solidFill>
                 <a:latin typeface="Calibri"/>
               </a:rPr>
@@ -5520,7 +5520,7 @@
             </a:avLst>
           </a:prstGeom>
           <a:solidFill>
-            <a:srgbClr val="22C55E"/>
+            <a:srgbClr val="0A84FF"/>
           </a:solidFill>
           <a:ln>
             <a:noFill/>
@@ -5662,7 +5662,7 @@
             <a:avLst/>
           </a:prstGeom>
           <a:solidFill>
-            <a:srgbClr val="6D28D9"/>
+            <a:srgbClr val="0071E3"/>
           </a:solidFill>
           <a:ln>
             <a:noFill/>
@@ -5772,7 +5772,7 @@
             <a:r>
               <a:rPr sz="1600" b="0" i="0">
                 <a:solidFill>
-                  <a:srgbClr val="1E1B2E"/>
+                  <a:srgbClr val="1D1D1F"/>
                 </a:solidFill>
                 <a:latin typeface="Calibri"/>
               </a:rPr>
@@ -5798,7 +5798,7 @@
             </a:avLst>
           </a:prstGeom>
           <a:solidFill>
-            <a:srgbClr val="F5A623"/>
+            <a:srgbClr val="5AC8FA"/>
           </a:solidFill>
           <a:ln>
             <a:noFill/>
@@ -5940,7 +5940,7 @@
             <a:avLst/>
           </a:prstGeom>
           <a:solidFill>
-            <a:srgbClr val="6D28D9"/>
+            <a:srgbClr val="0071E3"/>
           </a:solidFill>
           <a:ln>
             <a:noFill/>
@@ -6050,7 +6050,7 @@
             <a:r>
               <a:rPr sz="1600" b="0" i="0">
                 <a:solidFill>
-                  <a:srgbClr val="1E1B2E"/>
+                  <a:srgbClr val="1D1D1F"/>
                 </a:solidFill>
                 <a:latin typeface="Calibri"/>
               </a:rPr>
@@ -6076,7 +6076,7 @@
             </a:avLst>
           </a:prstGeom>
           <a:solidFill>
-            <a:srgbClr val="22C55E"/>
+            <a:srgbClr val="0A84FF"/>
           </a:solidFill>
           <a:ln>
             <a:noFill/>
@@ -6186,7 +6186,7 @@
             <a:r>
               <a:rPr sz="1200" b="1" i="0">
                 <a:solidFill>
-                  <a:srgbClr val="6B6680"/>
+                  <a:srgbClr val="86868B"/>
                 </a:solidFill>
                 <a:latin typeface="Calibri"/>
               </a:rPr>
@@ -6228,7 +6228,7 @@
             <a:avLst/>
           </a:prstGeom>
           <a:solidFill>
-            <a:srgbClr val="F6F4FD"/>
+            <a:srgbClr val="F5F5F7"/>
           </a:solidFill>
           <a:ln>
             <a:noFill/>
@@ -6274,7 +6274,7 @@
             </a:avLst>
           </a:prstGeom>
           <a:solidFill>
-            <a:srgbClr val="FB704C"/>
+            <a:srgbClr val="48484A"/>
           </a:solidFill>
           <a:ln>
             <a:noFill/>
@@ -6384,7 +6384,7 @@
             <a:r>
               <a:rPr sz="3400" b="1" i="0">
                 <a:solidFill>
-                  <a:srgbClr val="1E1B2E"/>
+                  <a:srgbClr val="1D1D1F"/>
                 </a:solidFill>
                 <a:latin typeface="Calibri"/>
               </a:rPr>
@@ -6408,7 +6408,7 @@
             <a:avLst/>
           </a:prstGeom>
           <a:solidFill>
-            <a:srgbClr val="FB704C"/>
+            <a:srgbClr val="48484A"/>
           </a:solidFill>
           <a:ln>
             <a:noFill/>
@@ -6660,7 +6660,7 @@
             <a:r>
               <a:rPr sz="1400" b="0" i="0">
                 <a:solidFill>
-                  <a:srgbClr val="1E1B2E"/>
+                  <a:srgbClr val="1D1D1F"/>
                 </a:solidFill>
                 <a:latin typeface="Calibri"/>
               </a:rPr>
@@ -6892,7 +6892,7 @@
             <a:r>
               <a:rPr sz="1400" b="0" i="0">
                 <a:solidFill>
-                  <a:srgbClr val="1E1B2E"/>
+                  <a:srgbClr val="1D1D1F"/>
                 </a:solidFill>
                 <a:latin typeface="Calibri"/>
               </a:rPr>
@@ -6969,7 +6969,7 @@
             <a:avLst/>
           </a:prstGeom>
           <a:solidFill>
-            <a:srgbClr val="14B8A6"/>
+            <a:srgbClr val="009DDC"/>
           </a:solidFill>
           <a:ln>
             <a:noFill/>
@@ -7079,7 +7079,7 @@
             <a:r>
               <a:rPr sz="1800" b="1" i="0">
                 <a:solidFill>
-                  <a:srgbClr val="14B8A6"/>
+                  <a:srgbClr val="009DDC"/>
                 </a:solidFill>
                 <a:latin typeface="Calibri"/>
               </a:rPr>
@@ -7124,7 +7124,7 @@
             <a:r>
               <a:rPr sz="1400" b="0" i="0">
                 <a:solidFill>
-                  <a:srgbClr val="1E1B2E"/>
+                  <a:srgbClr val="1D1D1F"/>
                 </a:solidFill>
                 <a:latin typeface="Calibri"/>
               </a:rPr>
@@ -7201,7 +7201,7 @@
             <a:avLst/>
           </a:prstGeom>
           <a:solidFill>
-            <a:srgbClr val="6D28D9"/>
+            <a:srgbClr val="0071E3"/>
           </a:solidFill>
           <a:ln>
             <a:noFill/>
@@ -7311,7 +7311,7 @@
             <a:r>
               <a:rPr sz="1800" b="1" i="0">
                 <a:solidFill>
-                  <a:srgbClr val="6D28D9"/>
+                  <a:srgbClr val="0071E3"/>
                 </a:solidFill>
                 <a:latin typeface="Calibri"/>
               </a:rPr>
@@ -7356,7 +7356,7 @@
             <a:r>
               <a:rPr sz="1400" b="0" i="0">
                 <a:solidFill>
-                  <a:srgbClr val="1E1B2E"/>
+                  <a:srgbClr val="1D1D1F"/>
                 </a:solidFill>
                 <a:latin typeface="Calibri"/>
               </a:rPr>
@@ -7401,7 +7401,7 @@
             <a:r>
               <a:rPr sz="1200" b="1" i="0">
                 <a:solidFill>
-                  <a:srgbClr val="6B6680"/>
+                  <a:srgbClr val="86868B"/>
                 </a:solidFill>
                 <a:latin typeface="Calibri"/>
               </a:rPr>
@@ -7445,10 +7445,10 @@
           <a:gradFill>
             <a:gsLst>
               <a:gs pos="0">
-                <a:srgbClr val="6D28D9"/>
+                <a:srgbClr val="0071E3"/>
               </a:gs>
               <a:gs pos="100000">
-                <a:srgbClr val="3B0A6B"/>
+                <a:srgbClr val="0A122A"/>
               </a:gs>
             </a:gsLst>
             <a:lin ang="7200000" scaled="1"/>
@@ -7497,10 +7497,10 @@
           <a:gradFill>
             <a:gsLst>
               <a:gs pos="0">
-                <a:srgbClr val="F5A623"/>
+                <a:srgbClr val="5AC8FA"/>
               </a:gs>
               <a:gs pos="100000">
-                <a:srgbClr val="FB704C"/>
+                <a:srgbClr val="48484A"/>
               </a:gs>
             </a:gsLst>
             <a:lin ang="2700000" scaled="1"/>
@@ -7549,10 +7549,10 @@
           <a:gradFill>
             <a:gsLst>
               <a:gs pos="0">
-                <a:srgbClr val="14B8A6"/>
+                <a:srgbClr val="009DDC"/>
               </a:gs>
               <a:gs pos="100000">
-                <a:srgbClr val="3B82F6"/>
+                <a:srgbClr val="1B6EF3"/>
               </a:gs>
             </a:gsLst>
             <a:lin ang="2700000" scaled="1"/>
@@ -7601,7 +7601,7 @@
             </a:avLst>
           </a:prstGeom>
           <a:solidFill>
-            <a:srgbClr val="F5A623"/>
+            <a:srgbClr val="5AC8FA"/>
           </a:solidFill>
           <a:ln>
             <a:noFill/>
@@ -7781,7 +7781,7 @@
             <a:avLst/>
           </a:prstGeom>
           <a:solidFill>
-            <a:srgbClr val="EC4B9C"/>
+            <a:srgbClr val="1428A0"/>
           </a:solidFill>
           <a:ln>
             <a:noFill/>
@@ -7846,7 +7846,7 @@
             <a:r>
               <a:rPr sz="1450" b="1" i="0">
                 <a:solidFill>
-                  <a:srgbClr val="EC4B9C"/>
+                  <a:srgbClr val="1428A0"/>
                 </a:solidFill>
                 <a:latin typeface="Calibri"/>
               </a:rPr>
@@ -7855,7 +7855,7 @@
             <a:r>
               <a:rPr sz="1400" b="0" i="0">
                 <a:solidFill>
-                  <a:srgbClr val="1E1B2E"/>
+                  <a:srgbClr val="1D1D1F"/>
                 </a:solidFill>
                 <a:latin typeface="Calibri"/>
               </a:rPr>
@@ -7925,7 +7925,7 @@
             <a:avLst/>
           </a:prstGeom>
           <a:solidFill>
-            <a:srgbClr val="14B8A6"/>
+            <a:srgbClr val="009DDC"/>
           </a:solidFill>
           <a:ln>
             <a:noFill/>
@@ -7990,7 +7990,7 @@
             <a:r>
               <a:rPr sz="1450" b="1" i="0">
                 <a:solidFill>
-                  <a:srgbClr val="14B8A6"/>
+                  <a:srgbClr val="009DDC"/>
                 </a:solidFill>
                 <a:latin typeface="Calibri"/>
               </a:rPr>
@@ -7999,7 +7999,7 @@
             <a:r>
               <a:rPr sz="1400" b="0" i="0">
                 <a:solidFill>
-                  <a:srgbClr val="1E1B2E"/>
+                  <a:srgbClr val="1D1D1F"/>
                 </a:solidFill>
                 <a:latin typeface="Calibri"/>
               </a:rPr>
@@ -8069,7 +8069,7 @@
             <a:avLst/>
           </a:prstGeom>
           <a:solidFill>
-            <a:srgbClr val="F5A623"/>
+            <a:srgbClr val="5AC8FA"/>
           </a:solidFill>
           <a:ln>
             <a:noFill/>
@@ -8134,7 +8134,7 @@
             <a:r>
               <a:rPr sz="1450" b="1" i="0">
                 <a:solidFill>
-                  <a:srgbClr val="F5A623"/>
+                  <a:srgbClr val="5AC8FA"/>
                 </a:solidFill>
                 <a:latin typeface="Calibri"/>
               </a:rPr>
@@ -8143,7 +8143,7 @@
             <a:r>
               <a:rPr sz="1400" b="0" i="0">
                 <a:solidFill>
-                  <a:srgbClr val="1E1B2E"/>
+                  <a:srgbClr val="1D1D1F"/>
                 </a:solidFill>
                 <a:latin typeface="Calibri"/>
               </a:rPr>
@@ -8213,7 +8213,7 @@
             <a:avLst/>
           </a:prstGeom>
           <a:solidFill>
-            <a:srgbClr val="FB704C"/>
+            <a:srgbClr val="48484A"/>
           </a:solidFill>
           <a:ln>
             <a:noFill/>
@@ -8278,7 +8278,7 @@
             <a:r>
               <a:rPr sz="1450" b="1" i="0">
                 <a:solidFill>
-                  <a:srgbClr val="FB704C"/>
+                  <a:srgbClr val="48484A"/>
                 </a:solidFill>
                 <a:latin typeface="Calibri"/>
               </a:rPr>
@@ -8287,7 +8287,7 @@
             <a:r>
               <a:rPr sz="1400" b="0" i="0">
                 <a:solidFill>
-                  <a:srgbClr val="1E1B2E"/>
+                  <a:srgbClr val="1D1D1F"/>
                 </a:solidFill>
                 <a:latin typeface="Calibri"/>
               </a:rPr>
@@ -8354,7 +8354,7 @@
             <a:r>
               <a:rPr sz="3000" b="1" i="0">
                 <a:solidFill>
-                  <a:srgbClr val="F5A623"/>
+                  <a:srgbClr val="5AC8FA"/>
                 </a:solidFill>
                 <a:latin typeface="Calibri"/>
               </a:rPr>
@@ -8376,7 +8376,7 @@
             <a:r>
               <a:rPr sz="1000" b="0" i="0">
                 <a:solidFill>
-                  <a:srgbClr val="1E1B2E"/>
+                  <a:srgbClr val="1D1D1F"/>
                 </a:solidFill>
                 <a:latin typeface="Calibri"/>
               </a:rPr>
@@ -8485,7 +8485,7 @@
             <a:avLst/>
           </a:prstGeom>
           <a:solidFill>
-            <a:srgbClr val="F6F4FD"/>
+            <a:srgbClr val="F5F5F7"/>
           </a:solidFill>
           <a:ln>
             <a:noFill/>
@@ -8531,7 +8531,7 @@
             </a:avLst>
           </a:prstGeom>
           <a:solidFill>
-            <a:srgbClr val="6D28D9"/>
+            <a:srgbClr val="0071E3"/>
           </a:solidFill>
           <a:ln>
             <a:noFill/>
@@ -8641,7 +8641,7 @@
             <a:r>
               <a:rPr sz="3400" b="1" i="0">
                 <a:solidFill>
-                  <a:srgbClr val="1E1B2E"/>
+                  <a:srgbClr val="1D1D1F"/>
                 </a:solidFill>
                 <a:latin typeface="Calibri"/>
               </a:rPr>
@@ -8665,7 +8665,7 @@
             <a:avLst/>
           </a:prstGeom>
           <a:solidFill>
-            <a:srgbClr val="6D28D9"/>
+            <a:srgbClr val="0071E3"/>
           </a:solidFill>
           <a:ln>
             <a:noFill/>
@@ -8783,7 +8783,7 @@
             <a:r>
               <a:rPr sz="2000" b="1" i="0">
                 <a:solidFill>
-                  <a:srgbClr val="EC4B9C"/>
+                  <a:srgbClr val="1428A0"/>
                 </a:solidFill>
                 <a:latin typeface="Calibri"/>
               </a:rPr>
@@ -8805,7 +8805,7 @@
             <a:r>
               <a:rPr sz="1600" b="0" i="0">
                 <a:solidFill>
-                  <a:srgbClr val="1E1B2E"/>
+                  <a:srgbClr val="1D1D1F"/>
                 </a:solidFill>
                 <a:latin typeface="Calibri"/>
               </a:rPr>
@@ -8827,7 +8827,7 @@
             <a:r>
               <a:rPr sz="600" b="0" i="0">
                 <a:solidFill>
-                  <a:srgbClr val="1E1B2E"/>
+                  <a:srgbClr val="1D1D1F"/>
                 </a:solidFill>
                 <a:latin typeface="Calibri"/>
               </a:rPr>
@@ -8849,7 +8849,7 @@
             <a:r>
               <a:rPr sz="1400" b="1" i="0">
                 <a:solidFill>
-                  <a:srgbClr val="6D28D9"/>
+                  <a:srgbClr val="0071E3"/>
                 </a:solidFill>
                 <a:latin typeface="Calibri"/>
               </a:rPr>
@@ -8871,7 +8871,7 @@
             <a:r>
               <a:rPr sz="1400" b="0" i="1">
                 <a:solidFill>
-                  <a:srgbClr val="6B6680"/>
+                  <a:srgbClr val="86868B"/>
                 </a:solidFill>
                 <a:latin typeface="Calibri"/>
               </a:rPr>
@@ -8948,7 +8948,7 @@
             <a:avLst/>
           </a:prstGeom>
           <a:solidFill>
-            <a:srgbClr val="6D28D9"/>
+            <a:srgbClr val="0071E3"/>
           </a:solidFill>
           <a:ln>
             <a:noFill/>
@@ -9058,7 +9058,7 @@
             <a:r>
               <a:rPr sz="1600" b="1" i="0">
                 <a:solidFill>
-                  <a:srgbClr val="1E1B2E"/>
+                  <a:srgbClr val="1D1D1F"/>
                 </a:solidFill>
                 <a:latin typeface="Calibri"/>
               </a:rPr>
@@ -9135,7 +9135,7 @@
             <a:avLst/>
           </a:prstGeom>
           <a:solidFill>
-            <a:srgbClr val="EC4B9C"/>
+            <a:srgbClr val="1428A0"/>
           </a:solidFill>
           <a:ln>
             <a:noFill/>
@@ -9245,7 +9245,7 @@
             <a:r>
               <a:rPr sz="1600" b="1" i="0">
                 <a:solidFill>
-                  <a:srgbClr val="1E1B2E"/>
+                  <a:srgbClr val="1D1D1F"/>
                 </a:solidFill>
                 <a:latin typeface="Calibri"/>
               </a:rPr>
@@ -9322,7 +9322,7 @@
             <a:avLst/>
           </a:prstGeom>
           <a:solidFill>
-            <a:srgbClr val="14B8A6"/>
+            <a:srgbClr val="009DDC"/>
           </a:solidFill>
           <a:ln>
             <a:noFill/>
@@ -9432,7 +9432,7 @@
             <a:r>
               <a:rPr sz="1600" b="1" i="0">
                 <a:solidFill>
-                  <a:srgbClr val="1E1B2E"/>
+                  <a:srgbClr val="1D1D1F"/>
                 </a:solidFill>
                 <a:latin typeface="Calibri"/>
               </a:rPr>
@@ -9509,7 +9509,7 @@
             <a:avLst/>
           </a:prstGeom>
           <a:solidFill>
-            <a:srgbClr val="F5A623"/>
+            <a:srgbClr val="5AC8FA"/>
           </a:solidFill>
           <a:ln>
             <a:noFill/>
@@ -9619,7 +9619,7 @@
             <a:r>
               <a:rPr sz="1600" b="1" i="0">
                 <a:solidFill>
-                  <a:srgbClr val="1E1B2E"/>
+                  <a:srgbClr val="1D1D1F"/>
                 </a:solidFill>
                 <a:latin typeface="Calibri"/>
               </a:rPr>
@@ -9696,7 +9696,7 @@
             <a:avLst/>
           </a:prstGeom>
           <a:solidFill>
-            <a:srgbClr val="FB704C"/>
+            <a:srgbClr val="48484A"/>
           </a:solidFill>
           <a:ln>
             <a:noFill/>
@@ -9806,7 +9806,7 @@
             <a:r>
               <a:rPr sz="1600" b="1" i="0">
                 <a:solidFill>
-                  <a:srgbClr val="1E1B2E"/>
+                  <a:srgbClr val="1D1D1F"/>
                 </a:solidFill>
                 <a:latin typeface="Calibri"/>
               </a:rPr>
@@ -9851,7 +9851,7 @@
             <a:r>
               <a:rPr sz="1200" b="1" i="0">
                 <a:solidFill>
-                  <a:srgbClr val="6B6680"/>
+                  <a:srgbClr val="86868B"/>
                 </a:solidFill>
                 <a:latin typeface="Calibri"/>
               </a:rPr>
@@ -9893,7 +9893,7 @@
             <a:avLst/>
           </a:prstGeom>
           <a:solidFill>
-            <a:srgbClr val="F6F4FD"/>
+            <a:srgbClr val="F5F5F7"/>
           </a:solidFill>
           <a:ln>
             <a:noFill/>
@@ -9939,7 +9939,7 @@
             </a:avLst>
           </a:prstGeom>
           <a:solidFill>
-            <a:srgbClr val="14B8A6"/>
+            <a:srgbClr val="009DDC"/>
           </a:solidFill>
           <a:ln>
             <a:noFill/>
@@ -10049,7 +10049,7 @@
             <a:r>
               <a:rPr sz="3400" b="1" i="0">
                 <a:solidFill>
-                  <a:srgbClr val="1E1B2E"/>
+                  <a:srgbClr val="1D1D1F"/>
                 </a:solidFill>
                 <a:latin typeface="Calibri"/>
               </a:rPr>
@@ -10073,7 +10073,7 @@
             <a:avLst/>
           </a:prstGeom>
           <a:solidFill>
-            <a:srgbClr val="14B8A6"/>
+            <a:srgbClr val="009DDC"/>
           </a:solidFill>
           <a:ln>
             <a:noFill/>
@@ -10170,7 +10170,7 @@
             <a:avLst/>
           </a:prstGeom>
           <a:solidFill>
-            <a:srgbClr val="6D28D9"/>
+            <a:srgbClr val="0071E3"/>
           </a:solidFill>
           <a:ln>
             <a:noFill/>
@@ -10235,7 +10235,7 @@
             <a:r>
               <a:rPr sz="2200" b="1" i="0">
                 <a:solidFill>
-                  <a:srgbClr val="6D28D9"/>
+                  <a:srgbClr val="0071E3"/>
                 </a:solidFill>
                 <a:latin typeface="Calibri"/>
               </a:rPr>
@@ -10280,7 +10280,7 @@
             <a:r>
               <a:rPr sz="1450" b="0" i="0">
                 <a:solidFill>
-                  <a:srgbClr val="1E1B2E"/>
+                  <a:srgbClr val="1D1D1F"/>
                 </a:solidFill>
                 <a:latin typeface="Calibri"/>
               </a:rPr>
@@ -10357,7 +10357,7 @@
             <a:avLst/>
           </a:prstGeom>
           <a:solidFill>
-            <a:srgbClr val="EC4B9C"/>
+            <a:srgbClr val="1428A0"/>
           </a:solidFill>
           <a:ln>
             <a:noFill/>
@@ -10422,7 +10422,7 @@
             <a:r>
               <a:rPr sz="2200" b="1" i="0">
                 <a:solidFill>
-                  <a:srgbClr val="EC4B9C"/>
+                  <a:srgbClr val="1428A0"/>
                 </a:solidFill>
                 <a:latin typeface="Calibri"/>
               </a:rPr>
@@ -10467,7 +10467,7 @@
             <a:r>
               <a:rPr sz="1450" b="0" i="0">
                 <a:solidFill>
-                  <a:srgbClr val="1E1B2E"/>
+                  <a:srgbClr val="1D1D1F"/>
                 </a:solidFill>
                 <a:latin typeface="Calibri"/>
               </a:rPr>
@@ -10544,7 +10544,7 @@
             <a:avLst/>
           </a:prstGeom>
           <a:solidFill>
-            <a:srgbClr val="14B8A6"/>
+            <a:srgbClr val="009DDC"/>
           </a:solidFill>
           <a:ln>
             <a:noFill/>
@@ -10609,7 +10609,7 @@
             <a:r>
               <a:rPr sz="2200" b="1" i="0">
                 <a:solidFill>
-                  <a:srgbClr val="14B8A6"/>
+                  <a:srgbClr val="009DDC"/>
                 </a:solidFill>
                 <a:latin typeface="Calibri"/>
               </a:rPr>
@@ -10654,7 +10654,7 @@
             <a:r>
               <a:rPr sz="1450" b="0" i="0">
                 <a:solidFill>
-                  <a:srgbClr val="1E1B2E"/>
+                  <a:srgbClr val="1D1D1F"/>
                 </a:solidFill>
                 <a:latin typeface="Calibri"/>
               </a:rPr>
@@ -10731,7 +10731,7 @@
             <a:avLst/>
           </a:prstGeom>
           <a:solidFill>
-            <a:srgbClr val="F5A623"/>
+            <a:srgbClr val="5AC8FA"/>
           </a:solidFill>
           <a:ln>
             <a:noFill/>
@@ -10796,7 +10796,7 @@
             <a:r>
               <a:rPr sz="2200" b="1" i="0">
                 <a:solidFill>
-                  <a:srgbClr val="F5A623"/>
+                  <a:srgbClr val="5AC8FA"/>
                 </a:solidFill>
                 <a:latin typeface="Calibri"/>
               </a:rPr>
@@ -10841,7 +10841,7 @@
             <a:r>
               <a:rPr sz="1450" b="0" i="0">
                 <a:solidFill>
-                  <a:srgbClr val="1E1B2E"/>
+                  <a:srgbClr val="1D1D1F"/>
                 </a:solidFill>
                 <a:latin typeface="Calibri"/>
               </a:rPr>
@@ -10886,7 +10886,7 @@
             <a:r>
               <a:rPr sz="1200" b="1" i="0">
                 <a:solidFill>
-                  <a:srgbClr val="6B6680"/>
+                  <a:srgbClr val="86868B"/>
                 </a:solidFill>
                 <a:latin typeface="Calibri"/>
               </a:rPr>
@@ -10928,7 +10928,7 @@
             <a:avLst/>
           </a:prstGeom>
           <a:solidFill>
-            <a:srgbClr val="3B0A6B"/>
+            <a:srgbClr val="0A122A"/>
           </a:solidFill>
           <a:ln>
             <a:noFill/>
@@ -10974,10 +10974,10 @@
           <a:gradFill>
             <a:gsLst>
               <a:gs pos="0">
-                <a:srgbClr val="EC4B9C"/>
+                <a:srgbClr val="1428A0"/>
               </a:gs>
               <a:gs pos="100000">
-                <a:srgbClr val="FB704C"/>
+                <a:srgbClr val="48484A"/>
               </a:gs>
             </a:gsLst>
             <a:lin ang="2700000" scaled="1"/>
@@ -11026,10 +11026,10 @@
           <a:gradFill>
             <a:gsLst>
               <a:gs pos="0">
-                <a:srgbClr val="14B8A6"/>
+                <a:srgbClr val="009DDC"/>
               </a:gs>
               <a:gs pos="100000">
-                <a:srgbClr val="3B82F6"/>
+                <a:srgbClr val="1B6EF3"/>
               </a:gs>
             </a:gsLst>
             <a:lin ang="2700000" scaled="1"/>
@@ -11078,7 +11078,7 @@
             </a:avLst>
           </a:prstGeom>
           <a:solidFill>
-            <a:srgbClr val="F5A623"/>
+            <a:srgbClr val="5AC8FA"/>
           </a:solidFill>
           <a:ln>
             <a:noFill/>
@@ -11212,7 +11212,7 @@
             <a:avLst/>
           </a:prstGeom>
           <a:solidFill>
-            <a:srgbClr val="F5A623"/>
+            <a:srgbClr val="5AC8FA"/>
           </a:solidFill>
           <a:ln>
             <a:noFill/>
@@ -11302,7 +11302,7 @@
             <a:avLst/>
           </a:prstGeom>
           <a:solidFill>
-            <a:srgbClr val="EC4B9C"/>
+            <a:srgbClr val="1428A0"/>
           </a:solidFill>
           <a:ln>
             <a:noFill/>
@@ -11412,7 +11412,7 @@
             <a:r>
               <a:rPr sz="1600" b="0" i="0">
                 <a:solidFill>
-                  <a:srgbClr val="1E1B2E"/>
+                  <a:srgbClr val="1D1D1F"/>
                 </a:solidFill>
                 <a:latin typeface="Calibri"/>
               </a:rPr>
@@ -11482,7 +11482,7 @@
             <a:avLst/>
           </a:prstGeom>
           <a:solidFill>
-            <a:srgbClr val="14B8A6"/>
+            <a:srgbClr val="009DDC"/>
           </a:solidFill>
           <a:ln>
             <a:noFill/>
@@ -11592,7 +11592,7 @@
             <a:r>
               <a:rPr sz="1600" b="0" i="0">
                 <a:solidFill>
-                  <a:srgbClr val="1E1B2E"/>
+                  <a:srgbClr val="1D1D1F"/>
                 </a:solidFill>
                 <a:latin typeface="Calibri"/>
               </a:rPr>
@@ -11662,7 +11662,7 @@
             <a:avLst/>
           </a:prstGeom>
           <a:solidFill>
-            <a:srgbClr val="F5A623"/>
+            <a:srgbClr val="5AC8FA"/>
           </a:solidFill>
           <a:ln>
             <a:noFill/>
@@ -11772,7 +11772,7 @@
             <a:r>
               <a:rPr sz="1600" b="0" i="0">
                 <a:solidFill>
-                  <a:srgbClr val="1E1B2E"/>
+                  <a:srgbClr val="1D1D1F"/>
                 </a:solidFill>
                 <a:latin typeface="Calibri"/>
               </a:rPr>
@@ -11842,7 +11842,7 @@
             <a:avLst/>
           </a:prstGeom>
           <a:solidFill>
-            <a:srgbClr val="FB704C"/>
+            <a:srgbClr val="48484A"/>
           </a:solidFill>
           <a:ln>
             <a:noFill/>
@@ -11952,7 +11952,7 @@
             <a:r>
               <a:rPr sz="1600" b="0" i="0">
                 <a:solidFill>
-                  <a:srgbClr val="1E1B2E"/>
+                  <a:srgbClr val="1D1D1F"/>
                 </a:solidFill>
                 <a:latin typeface="Calibri"/>
               </a:rPr>
@@ -12039,7 +12039,7 @@
             <a:avLst/>
           </a:prstGeom>
           <a:solidFill>
-            <a:srgbClr val="F6F4FD"/>
+            <a:srgbClr val="F5F5F7"/>
           </a:solidFill>
           <a:ln>
             <a:noFill/>
@@ -12085,7 +12085,7 @@
             </a:avLst>
           </a:prstGeom>
           <a:solidFill>
-            <a:srgbClr val="EC4B9C"/>
+            <a:srgbClr val="1428A0"/>
           </a:solidFill>
           <a:ln>
             <a:noFill/>
@@ -12195,7 +12195,7 @@
             <a:r>
               <a:rPr sz="3400" b="1" i="0">
                 <a:solidFill>
-                  <a:srgbClr val="1E1B2E"/>
+                  <a:srgbClr val="1D1D1F"/>
                 </a:solidFill>
                 <a:latin typeface="Calibri"/>
               </a:rPr>
@@ -12219,7 +12219,7 @@
             <a:avLst/>
           </a:prstGeom>
           <a:solidFill>
-            <a:srgbClr val="EC4B9C"/>
+            <a:srgbClr val="1428A0"/>
           </a:solidFill>
           <a:ln>
             <a:noFill/>
@@ -12267,10 +12267,10 @@
           <a:gradFill>
             <a:gsLst>
               <a:gs pos="0">
-                <a:srgbClr val="6D28D9"/>
+                <a:srgbClr val="0071E3"/>
               </a:gs>
               <a:gs pos="100000">
-                <a:srgbClr val="8B46FF"/>
+                <a:srgbClr val="1E8FFF"/>
               </a:gs>
             </a:gsLst>
             <a:lin ang="2700000" scaled="1"/>
@@ -12463,10 +12463,10 @@
           <a:gradFill>
             <a:gsLst>
               <a:gs pos="0">
-                <a:srgbClr val="14B8A6"/>
+                <a:srgbClr val="009DDC"/>
               </a:gs>
               <a:gs pos="100000">
-                <a:srgbClr val="32D6CE"/>
+                <a:srgbClr val="1EBBFF"/>
               </a:gs>
             </a:gsLst>
             <a:lin ang="2700000" scaled="1"/>
@@ -12659,10 +12659,10 @@
           <a:gradFill>
             <a:gsLst>
               <a:gs pos="0">
-                <a:srgbClr val="F5A623"/>
+                <a:srgbClr val="5AC8FA"/>
               </a:gs>
               <a:gs pos="100000">
-                <a:srgbClr val="FFC44B"/>
+                <a:srgbClr val="78E6FF"/>
               </a:gs>
             </a:gsLst>
             <a:lin ang="2700000" scaled="1"/>
@@ -12872,7 +12872,7 @@
             <a:r>
               <a:rPr sz="1600" b="1" i="0">
                 <a:solidFill>
-                  <a:srgbClr val="1E1B2E"/>
+                  <a:srgbClr val="1D1D1F"/>
                 </a:solidFill>
                 <a:latin typeface="Calibri"/>
               </a:rPr>
@@ -12898,7 +12898,7 @@
             </a:avLst>
           </a:prstGeom>
           <a:solidFill>
-            <a:srgbClr val="6D28D9"/>
+            <a:srgbClr val="0071E3"/>
           </a:solidFill>
           <a:ln>
             <a:noFill/>
@@ -12989,7 +12989,7 @@
             </a:avLst>
           </a:prstGeom>
           <a:solidFill>
-            <a:srgbClr val="EC4B9C"/>
+            <a:srgbClr val="1428A0"/>
           </a:solidFill>
           <a:ln>
             <a:noFill/>
@@ -13080,7 +13080,7 @@
             </a:avLst>
           </a:prstGeom>
           <a:solidFill>
-            <a:srgbClr val="14B8A6"/>
+            <a:srgbClr val="009DDC"/>
           </a:solidFill>
           <a:ln>
             <a:noFill/>
@@ -13171,7 +13171,7 @@
             </a:avLst>
           </a:prstGeom>
           <a:solidFill>
-            <a:srgbClr val="F5A623"/>
+            <a:srgbClr val="5AC8FA"/>
           </a:solidFill>
           <a:ln>
             <a:noFill/>
@@ -13281,7 +13281,7 @@
             <a:r>
               <a:rPr sz="1200" b="1" i="0">
                 <a:solidFill>
-                  <a:srgbClr val="6B6680"/>
+                  <a:srgbClr val="86868B"/>
                 </a:solidFill>
                 <a:latin typeface="Calibri"/>
               </a:rPr>
@@ -13323,7 +13323,7 @@
             <a:avLst/>
           </a:prstGeom>
           <a:solidFill>
-            <a:srgbClr val="F6F4FD"/>
+            <a:srgbClr val="F5F5F7"/>
           </a:solidFill>
           <a:ln>
             <a:noFill/>
@@ -13369,7 +13369,7 @@
             </a:avLst>
           </a:prstGeom>
           <a:solidFill>
-            <a:srgbClr val="3B82F6"/>
+            <a:srgbClr val="1B6EF3"/>
           </a:solidFill>
           <a:ln>
             <a:noFill/>
@@ -13479,7 +13479,7 @@
             <a:r>
               <a:rPr sz="3400" b="1" i="0">
                 <a:solidFill>
-                  <a:srgbClr val="1E1B2E"/>
+                  <a:srgbClr val="1D1D1F"/>
                 </a:solidFill>
                 <a:latin typeface="Calibri"/>
               </a:rPr>
@@ -13503,7 +13503,7 @@
             <a:avLst/>
           </a:prstGeom>
           <a:solidFill>
-            <a:srgbClr val="3B82F6"/>
+            <a:srgbClr val="1B6EF3"/>
           </a:solidFill>
           <a:ln>
             <a:noFill/>
@@ -13551,10 +13551,10 @@
           <a:gradFill>
             <a:gsLst>
               <a:gs pos="0">
-                <a:srgbClr val="EC4B9C"/>
+                <a:srgbClr val="1428A0"/>
               </a:gs>
               <a:gs pos="100000">
-                <a:srgbClr val="FB704C"/>
+                <a:srgbClr val="48484A"/>
               </a:gs>
             </a:gsLst>
             <a:lin ang="2700000" scaled="1"/>
@@ -13732,7 +13732,7 @@
             <a:r>
               <a:rPr sz="1250" b="0" i="1">
                 <a:solidFill>
-                  <a:srgbClr val="6B6680"/>
+                  <a:srgbClr val="86868B"/>
                 </a:solidFill>
                 <a:latin typeface="Calibri"/>
               </a:rPr>
@@ -13777,7 +13777,7 @@
             <a:r>
               <a:rPr sz="1200" b="1" i="0">
                 <a:solidFill>
-                  <a:srgbClr val="6B6680"/>
+                  <a:srgbClr val="86868B"/>
                 </a:solidFill>
                 <a:latin typeface="Calibri"/>
               </a:rPr>
@@ -13819,7 +13819,7 @@
             <a:avLst/>
           </a:prstGeom>
           <a:solidFill>
-            <a:srgbClr val="F6F4FD"/>
+            <a:srgbClr val="F5F5F7"/>
           </a:solidFill>
           <a:ln>
             <a:noFill/>
@@ -13865,7 +13865,7 @@
             </a:avLst>
           </a:prstGeom>
           <a:solidFill>
-            <a:srgbClr val="6D28D9"/>
+            <a:srgbClr val="0071E3"/>
           </a:solidFill>
           <a:ln>
             <a:noFill/>
@@ -13975,7 +13975,7 @@
             <a:r>
               <a:rPr sz="3400" b="1" i="0">
                 <a:solidFill>
-                  <a:srgbClr val="1E1B2E"/>
+                  <a:srgbClr val="1D1D1F"/>
                 </a:solidFill>
                 <a:latin typeface="Calibri"/>
               </a:rPr>
@@ -13999,7 +13999,7 @@
             <a:avLst/>
           </a:prstGeom>
           <a:solidFill>
-            <a:srgbClr val="6D28D9"/>
+            <a:srgbClr val="0071E3"/>
           </a:solidFill>
           <a:ln>
             <a:noFill/>
@@ -14135,7 +14135,7 @@
             <a:r>
               <a:rPr sz="1600" b="1" i="0">
                 <a:solidFill>
-                  <a:srgbClr val="22C55E"/>
+                  <a:srgbClr val="0A84FF"/>
                 </a:solidFill>
                 <a:latin typeface="Calibri"/>
               </a:rPr>
@@ -14157,7 +14157,7 @@
             <a:r>
               <a:rPr sz="400" b="0" i="0">
                 <a:solidFill>
-                  <a:srgbClr val="1E1B2E"/>
+                  <a:srgbClr val="1D1D1F"/>
                 </a:solidFill>
                 <a:latin typeface="Calibri"/>
               </a:rPr>
@@ -14201,7 +14201,7 @@
             <a:r>
               <a:rPr sz="1250" b="0" i="0">
                 <a:solidFill>
-                  <a:srgbClr val="1E1B2E"/>
+                  <a:srgbClr val="1D1D1F"/>
                 </a:solidFill>
                 <a:latin typeface="Calibri"/>
               </a:rPr>
@@ -14223,7 +14223,7 @@
             <a:r>
               <a:rPr sz="400" b="0" i="0">
                 <a:solidFill>
-                  <a:srgbClr val="1E1B2E"/>
+                  <a:srgbClr val="1D1D1F"/>
                 </a:solidFill>
                 <a:latin typeface="Calibri"/>
               </a:rPr>
@@ -14267,7 +14267,7 @@
             <a:r>
               <a:rPr sz="1250" b="0" i="0">
                 <a:solidFill>
-                  <a:srgbClr val="1E1B2E"/>
+                  <a:srgbClr val="1D1D1F"/>
                 </a:solidFill>
                 <a:latin typeface="Calibri"/>
               </a:rPr>
@@ -14289,7 +14289,7 @@
             <a:r>
               <a:rPr sz="400" b="0" i="0">
                 <a:solidFill>
-                  <a:srgbClr val="1E1B2E"/>
+                  <a:srgbClr val="1D1D1F"/>
                 </a:solidFill>
                 <a:latin typeface="Calibri"/>
               </a:rPr>
@@ -14311,7 +14311,7 @@
             <a:r>
               <a:rPr sz="1250" b="0" i="1">
                 <a:solidFill>
-                  <a:srgbClr val="6B6680"/>
+                  <a:srgbClr val="86868B"/>
                 </a:solidFill>
                 <a:latin typeface="Calibri"/>
               </a:rPr>
@@ -14356,7 +14356,7 @@
             <a:r>
               <a:rPr sz="1200" b="1" i="0">
                 <a:solidFill>
-                  <a:srgbClr val="6B6680"/>
+                  <a:srgbClr val="86868B"/>
                 </a:solidFill>
                 <a:latin typeface="Calibri"/>
               </a:rPr>
@@ -14398,7 +14398,7 @@
             <a:avLst/>
           </a:prstGeom>
           <a:solidFill>
-            <a:srgbClr val="F6F4FD"/>
+            <a:srgbClr val="F5F5F7"/>
           </a:solidFill>
           <a:ln>
             <a:noFill/>
@@ -14444,7 +14444,7 @@
             </a:avLst>
           </a:prstGeom>
           <a:solidFill>
-            <a:srgbClr val="EC4B9C"/>
+            <a:srgbClr val="1428A0"/>
           </a:solidFill>
           <a:ln>
             <a:noFill/>
@@ -14554,7 +14554,7 @@
             <a:r>
               <a:rPr sz="3400" b="1" i="0">
                 <a:solidFill>
-                  <a:srgbClr val="1E1B2E"/>
+                  <a:srgbClr val="1D1D1F"/>
                 </a:solidFill>
                 <a:latin typeface="Calibri"/>
               </a:rPr>
@@ -14578,7 +14578,7 @@
             <a:avLst/>
           </a:prstGeom>
           <a:solidFill>
-            <a:srgbClr val="EC4B9C"/>
+            <a:srgbClr val="1428A0"/>
           </a:solidFill>
           <a:ln>
             <a:noFill/>
@@ -14714,7 +14714,7 @@
             <a:r>
               <a:rPr sz="1500" b="1" i="0">
                 <a:solidFill>
-                  <a:srgbClr val="6D28D9"/>
+                  <a:srgbClr val="0071E3"/>
                 </a:solidFill>
                 <a:latin typeface="Calibri"/>
               </a:rPr>
@@ -14736,7 +14736,7 @@
             <a:r>
               <a:rPr sz="1400" b="0" i="0">
                 <a:solidFill>
-                  <a:srgbClr val="1E1B2E"/>
+                  <a:srgbClr val="1D1D1F"/>
                 </a:solidFill>
                 <a:latin typeface="Calibri"/>
               </a:rPr>
@@ -14758,7 +14758,7 @@
             <a:r>
               <a:rPr sz="1400" b="0" i="0">
                 <a:solidFill>
-                  <a:srgbClr val="1E1B2E"/>
+                  <a:srgbClr val="1D1D1F"/>
                 </a:solidFill>
                 <a:latin typeface="Calibri"/>
               </a:rPr>
@@ -14780,7 +14780,7 @@
             <a:r>
               <a:rPr sz="1400" b="0" i="0">
                 <a:solidFill>
-                  <a:srgbClr val="6B6680"/>
+                  <a:srgbClr val="86868B"/>
                 </a:solidFill>
                 <a:latin typeface="Calibri"/>
               </a:rPr>
@@ -14808,10 +14808,10 @@
           <a:gradFill>
             <a:gsLst>
               <a:gs pos="0">
-                <a:srgbClr val="22C55E"/>
+                <a:srgbClr val="0A84FF"/>
               </a:gs>
               <a:gs pos="100000">
-                <a:srgbClr val="14B8A6"/>
+                <a:srgbClr val="009DDC"/>
               </a:gs>
             </a:gsLst>
             <a:lin ang="2700000" scaled="1"/>
@@ -14958,10 +14958,10 @@
           <a:gradFill>
             <a:gsLst>
               <a:gs pos="0">
-                <a:srgbClr val="F5A623"/>
+                <a:srgbClr val="5AC8FA"/>
               </a:gs>
               <a:gs pos="100000">
-                <a:srgbClr val="FB704C"/>
+                <a:srgbClr val="48484A"/>
               </a:gs>
             </a:gsLst>
             <a:lin ang="2700000" scaled="1"/>
@@ -15125,7 +15125,7 @@
             <a:r>
               <a:rPr sz="1200" b="1" i="0">
                 <a:solidFill>
-                  <a:srgbClr val="6B6680"/>
+                  <a:srgbClr val="86868B"/>
                 </a:solidFill>
                 <a:latin typeface="Calibri"/>
               </a:rPr>
@@ -15167,7 +15167,7 @@
             <a:avLst/>
           </a:prstGeom>
           <a:solidFill>
-            <a:srgbClr val="3B0A6B"/>
+            <a:srgbClr val="0A122A"/>
           </a:solidFill>
           <a:ln>
             <a:noFill/>
@@ -15213,10 +15213,10 @@
           <a:gradFill>
             <a:gsLst>
               <a:gs pos="0">
-                <a:srgbClr val="14B8A6"/>
+                <a:srgbClr val="009DDC"/>
               </a:gs>
               <a:gs pos="100000">
-                <a:srgbClr val="3B82F6"/>
+                <a:srgbClr val="1B6EF3"/>
               </a:gs>
             </a:gsLst>
             <a:lin ang="2700000" scaled="1"/>
@@ -15265,10 +15265,10 @@
           <a:gradFill>
             <a:gsLst>
               <a:gs pos="0">
-                <a:srgbClr val="EC4B9C"/>
+                <a:srgbClr val="1428A0"/>
               </a:gs>
               <a:gs pos="100000">
-                <a:srgbClr val="FB704C"/>
+                <a:srgbClr val="48484A"/>
               </a:gs>
             </a:gsLst>
             <a:lin ang="2700000" scaled="1"/>
@@ -15317,7 +15317,7 @@
             </a:avLst>
           </a:prstGeom>
           <a:solidFill>
-            <a:srgbClr val="F5A623"/>
+            <a:srgbClr val="5AC8FA"/>
           </a:solidFill>
           <a:ln>
             <a:noFill/>
@@ -15451,7 +15451,7 @@
             <a:avLst/>
           </a:prstGeom>
           <a:solidFill>
-            <a:srgbClr val="F5A623"/>
+            <a:srgbClr val="5AC8FA"/>
           </a:solidFill>
           <a:ln>
             <a:noFill/>
@@ -15516,7 +15516,7 @@
             <a:r>
               <a:rPr sz="10000" b="1" i="0">
                 <a:solidFill>
-                  <a:srgbClr val="F5A623"/>
+                  <a:srgbClr val="5AC8FA"/>
                 </a:solidFill>
                 <a:latin typeface="Calibri"/>
               </a:rPr>
@@ -15692,7 +15692,7 @@
             <a:r>
               <a:rPr sz="1500" b="1" i="0">
                 <a:solidFill>
-                  <a:srgbClr val="6D28D9"/>
+                  <a:srgbClr val="0071E3"/>
                 </a:solidFill>
                 <a:latin typeface="Calibri"/>
               </a:rPr>
@@ -15701,7 +15701,7 @@
             <a:r>
               <a:rPr sz="1300" b="0" i="0">
                 <a:solidFill>
-                  <a:srgbClr val="1E1B2E"/>
+                  <a:srgbClr val="1D1D1F"/>
                 </a:solidFill>
                 <a:latin typeface="Calibri"/>
               </a:rPr>

</xml_diff>